<commit_message>
On branch main  Your branch is up to date with 'origin/main'.
 Changes to be committed:
	modified:   automation/export_ppt.py
	modified:   automation/filter.py
	modified:   automation/pipeline.py
	new file:   automation/s3_integration.py
	modified:   dataconfig/data.py
	modified:   dataconfig/db_config.py
	modified:   dataconfig/mapping.py
	modified:   main.py
	modified:   requirements.txt
	modified:   template/query_templates.py
	modified:   template/template_infografis.pptx
	modified:   template/template_infografis_nasional.pptx
</commit_message>
<xml_diff>
--- a/template/template_infografis_nasional.pptx
+++ b/template/template_infografis_nasional.pptx
@@ -15,23 +15,20 @@
   <p:embeddedFontLst>
     <p:embeddedFont>
       <p:font typeface="Arial Bold" panose="020B0704020202020204" pitchFamily="34" charset="0"/>
-      <p:regular r:id="rId4"/>
-      <p:bold r:id="rId5"/>
+      <p:bold r:id="rId4"/>
     </p:embeddedFont>
     <p:embeddedFont>
       <p:font typeface="Open Sans" panose="020B0606030504020204" pitchFamily="34" charset="0"/>
-      <p:regular r:id="rId6"/>
-      <p:bold r:id="rId7"/>
-      <p:italic r:id="rId8"/>
-      <p:boldItalic r:id="rId9"/>
+      <p:regular r:id="rId5"/>
+      <p:bold r:id="rId6"/>
     </p:embeddedFont>
     <p:embeddedFont>
-      <p:font typeface="Open Sans Bold" panose="020B0806030504020204" charset="0"/>
-      <p:regular r:id="rId10"/>
+      <p:font typeface="Open Sans Bold" panose="020B0806030504020204" pitchFamily="34" charset="0"/>
+      <p:bold r:id="rId7"/>
     </p:embeddedFont>
     <p:embeddedFont>
       <p:font typeface="Open Sans Bold Italics" panose="020B0604020202020204" charset="0"/>
-      <p:regular r:id="rId11"/>
+      <p:regular r:id="rId8"/>
     </p:embeddedFont>
   </p:embeddedFontLst>
   <p:defaultTextStyle>
@@ -148,1181 +145,37 @@
 </p:presentation>
 </file>
 
-<file path=ppt/revisionInfo.xml><?xml version="1.0" encoding="utf-8"?>
-<p1510:revInfo xmlns:a="http://schemas.openxmlformats.org/drawingml/2006/main" xmlns:r="http://schemas.openxmlformats.org/officeDocument/2006/relationships" xmlns:p1510="http://schemas.microsoft.com/office/powerpoint/2015/10/main">
-  <p1510:revLst>
-    <p1510:client id="{A5075CDD-B918-483B-A610-DDEF6BBEB30D}" v="21" dt="2026-06-02T02:22:31.807"/>
-  </p1510:revLst>
-</p1510:revInfo>
-</file>
-
 <file path=ppt/changesInfos/changesInfo1.xml><?xml version="1.0" encoding="utf-8"?>
 <pc:chgInfo xmlns:a="http://schemas.openxmlformats.org/drawingml/2006/main" xmlns:r="http://schemas.openxmlformats.org/officeDocument/2006/relationships" xmlns:ac="http://schemas.microsoft.com/office/drawing/2013/main/command" xmlns:pc="http://schemas.microsoft.com/office/powerpoint/2013/main/command">
   <pc:docChgLst>
     <pc:chgData name="Yofadikara Nurrohman" userId="92e6fe32f2f0c507" providerId="LiveId" clId="{FDC5BF04-28D9-4B06-A8F3-DEC669F7CDC1}"/>
     <pc:docChg chg="undo redo custSel modSld">
-      <pc:chgData name="Yofadikara Nurrohman" userId="92e6fe32f2f0c507" providerId="LiveId" clId="{FDC5BF04-28D9-4B06-A8F3-DEC669F7CDC1}" dt="2026-06-02T08:52:47.993" v="221" actId="207"/>
+      <pc:chgData name="Yofadikara Nurrohman" userId="92e6fe32f2f0c507" providerId="LiveId" clId="{FDC5BF04-28D9-4B06-A8F3-DEC669F7CDC1}" dt="2026-09-17T02:17:08.579" v="224" actId="404"/>
       <pc:docMkLst>
         <pc:docMk/>
       </pc:docMkLst>
       <pc:sldChg chg="addSp delSp modSp mod">
-        <pc:chgData name="Yofadikara Nurrohman" userId="92e6fe32f2f0c507" providerId="LiveId" clId="{FDC5BF04-28D9-4B06-A8F3-DEC669F7CDC1}" dt="2026-06-02T08:52:47.993" v="221" actId="207"/>
+        <pc:chgData name="Yofadikara Nurrohman" userId="92e6fe32f2f0c507" providerId="LiveId" clId="{FDC5BF04-28D9-4B06-A8F3-DEC669F7CDC1}" dt="2026-09-17T02:17:08.579" v="224" actId="404"/>
         <pc:sldMkLst>
           <pc:docMk/>
           <pc:sldMk cId="0" sldId="256"/>
         </pc:sldMkLst>
         <pc:spChg chg="mod">
-          <ac:chgData name="Yofadikara Nurrohman" userId="92e6fe32f2f0c507" providerId="LiveId" clId="{FDC5BF04-28D9-4B06-A8F3-DEC669F7CDC1}" dt="2026-06-02T02:07:10.713" v="6"/>
+          <ac:chgData name="Yofadikara Nurrohman" userId="92e6fe32f2f0c507" providerId="LiveId" clId="{FDC5BF04-28D9-4B06-A8F3-DEC669F7CDC1}" dt="2026-09-17T02:17:08.579" v="224" actId="404"/>
           <ac:spMkLst>
             <pc:docMk/>
             <pc:sldMk cId="0" sldId="256"/>
-            <ac:spMk id="6" creationId="{5EE541BF-498F-3767-A6CF-08191AA2EDDC}"/>
+            <ac:spMk id="312" creationId="{307BD22F-5BFA-98F3-634E-DB3748BBCB7E}"/>
           </ac:spMkLst>
         </pc:spChg>
         <pc:spChg chg="mod">
-          <ac:chgData name="Yofadikara Nurrohman" userId="92e6fe32f2f0c507" providerId="LiveId" clId="{FDC5BF04-28D9-4B06-A8F3-DEC669F7CDC1}" dt="2026-06-02T02:32:11.175" v="200" actId="208"/>
-          <ac:spMkLst>
-            <pc:docMk/>
-            <pc:sldMk cId="0" sldId="256"/>
-            <ac:spMk id="8" creationId="{00000000-0000-0000-0000-000000000000}"/>
-          </ac:spMkLst>
-        </pc:spChg>
-        <pc:spChg chg="mod">
-          <ac:chgData name="Yofadikara Nurrohman" userId="92e6fe32f2f0c507" providerId="LiveId" clId="{FDC5BF04-28D9-4B06-A8F3-DEC669F7CDC1}" dt="2026-06-02T02:26:16.050" v="145" actId="207"/>
-          <ac:spMkLst>
-            <pc:docMk/>
-            <pc:sldMk cId="0" sldId="256"/>
-            <ac:spMk id="14" creationId="{00000000-0000-0000-0000-000000000000}"/>
-          </ac:spMkLst>
-        </pc:spChg>
-        <pc:spChg chg="mod">
-          <ac:chgData name="Yofadikara Nurrohman" userId="92e6fe32f2f0c507" providerId="LiveId" clId="{FDC5BF04-28D9-4B06-A8F3-DEC669F7CDC1}" dt="2026-06-02T02:32:07.762" v="199" actId="208"/>
-          <ac:spMkLst>
-            <pc:docMk/>
-            <pc:sldMk cId="0" sldId="256"/>
-            <ac:spMk id="17" creationId="{00000000-0000-0000-0000-000000000000}"/>
-          </ac:spMkLst>
-        </pc:spChg>
-        <pc:spChg chg="mod">
-          <ac:chgData name="Yofadikara Nurrohman" userId="92e6fe32f2f0c507" providerId="LiveId" clId="{FDC5BF04-28D9-4B06-A8F3-DEC669F7CDC1}" dt="2026-06-02T02:31:55.764" v="191" actId="208"/>
-          <ac:spMkLst>
-            <pc:docMk/>
-            <pc:sldMk cId="0" sldId="256"/>
-            <ac:spMk id="18" creationId="{00000000-0000-0000-0000-000000000000}"/>
-          </ac:spMkLst>
-        </pc:spChg>
-        <pc:spChg chg="mod">
-          <ac:chgData name="Yofadikara Nurrohman" userId="92e6fe32f2f0c507" providerId="LiveId" clId="{FDC5BF04-28D9-4B06-A8F3-DEC669F7CDC1}" dt="2026-06-02T02:25:54.816" v="137" actId="207"/>
-          <ac:spMkLst>
-            <pc:docMk/>
-            <pc:sldMk cId="0" sldId="256"/>
-            <ac:spMk id="20" creationId="{00000000-0000-0000-0000-000000000000}"/>
-          </ac:spMkLst>
-        </pc:spChg>
-        <pc:spChg chg="mod topLvl">
-          <ac:chgData name="Yofadikara Nurrohman" userId="92e6fe32f2f0c507" providerId="LiveId" clId="{FDC5BF04-28D9-4B06-A8F3-DEC669F7CDC1}" dt="2026-06-02T02:32:34.832" v="205" actId="478"/>
-          <ac:spMkLst>
-            <pc:docMk/>
-            <pc:sldMk cId="0" sldId="256"/>
-            <ac:spMk id="22" creationId="{00000000-0000-0000-0000-000000000000}"/>
-          </ac:spMkLst>
-        </pc:spChg>
-        <pc:spChg chg="del mod topLvl">
-          <ac:chgData name="Yofadikara Nurrohman" userId="92e6fe32f2f0c507" providerId="LiveId" clId="{FDC5BF04-28D9-4B06-A8F3-DEC669F7CDC1}" dt="2026-06-02T02:32:34.832" v="205" actId="478"/>
-          <ac:spMkLst>
-            <pc:docMk/>
-            <pc:sldMk cId="0" sldId="256"/>
-            <ac:spMk id="23" creationId="{00000000-0000-0000-0000-000000000000}"/>
-          </ac:spMkLst>
-        </pc:spChg>
-        <pc:spChg chg="mod">
-          <ac:chgData name="Yofadikara Nurrohman" userId="92e6fe32f2f0c507" providerId="LiveId" clId="{FDC5BF04-28D9-4B06-A8F3-DEC669F7CDC1}" dt="2026-06-02T02:28:38.409" v="175" actId="208"/>
-          <ac:spMkLst>
-            <pc:docMk/>
-            <pc:sldMk cId="0" sldId="256"/>
-            <ac:spMk id="25" creationId="{00000000-0000-0000-0000-000000000000}"/>
-          </ac:spMkLst>
-        </pc:spChg>
-        <pc:spChg chg="mod">
-          <ac:chgData name="Yofadikara Nurrohman" userId="92e6fe32f2f0c507" providerId="LiveId" clId="{FDC5BF04-28D9-4B06-A8F3-DEC669F7CDC1}" dt="2026-06-02T02:07:10.713" v="6"/>
-          <ac:spMkLst>
-            <pc:docMk/>
-            <pc:sldMk cId="0" sldId="256"/>
-            <ac:spMk id="29" creationId="{82C5796D-0A20-651D-E39A-C447A49FB322}"/>
-          </ac:spMkLst>
-        </pc:spChg>
-        <pc:spChg chg="mod">
-          <ac:chgData name="Yofadikara Nurrohman" userId="92e6fe32f2f0c507" providerId="LiveId" clId="{FDC5BF04-28D9-4B06-A8F3-DEC669F7CDC1}" dt="2026-06-02T02:21:41.018" v="56" actId="207"/>
-          <ac:spMkLst>
-            <pc:docMk/>
-            <pc:sldMk cId="0" sldId="256"/>
-            <ac:spMk id="31" creationId="{00000000-0000-0000-0000-000000000000}"/>
-          </ac:spMkLst>
-        </pc:spChg>
-        <pc:spChg chg="mod">
-          <ac:chgData name="Yofadikara Nurrohman" userId="92e6fe32f2f0c507" providerId="LiveId" clId="{FDC5BF04-28D9-4B06-A8F3-DEC669F7CDC1}" dt="2026-06-02T02:20:32.874" v="47" actId="207"/>
-          <ac:spMkLst>
-            <pc:docMk/>
-            <pc:sldMk cId="0" sldId="256"/>
-            <ac:spMk id="36" creationId="{00000000-0000-0000-0000-000000000000}"/>
-          </ac:spMkLst>
-        </pc:spChg>
-        <pc:spChg chg="mod">
-          <ac:chgData name="Yofadikara Nurrohman" userId="92e6fe32f2f0c507" providerId="LiveId" clId="{FDC5BF04-28D9-4B06-A8F3-DEC669F7CDC1}" dt="2026-06-02T02:20:24.604" v="45" actId="20577"/>
-          <ac:spMkLst>
-            <pc:docMk/>
-            <pc:sldMk cId="0" sldId="256"/>
-            <ac:spMk id="38" creationId="{00000000-0000-0000-0000-000000000000}"/>
-          </ac:spMkLst>
-        </pc:spChg>
-        <pc:spChg chg="mod">
-          <ac:chgData name="Yofadikara Nurrohman" userId="92e6fe32f2f0c507" providerId="LiveId" clId="{FDC5BF04-28D9-4B06-A8F3-DEC669F7CDC1}" dt="2026-06-02T02:24:15.222" v="111" actId="207"/>
-          <ac:spMkLst>
-            <pc:docMk/>
-            <pc:sldMk cId="0" sldId="256"/>
-            <ac:spMk id="40" creationId="{00000000-0000-0000-0000-000000000000}"/>
-          </ac:spMkLst>
-        </pc:spChg>
-        <pc:spChg chg="mod">
-          <ac:chgData name="Yofadikara Nurrohman" userId="92e6fe32f2f0c507" providerId="LiveId" clId="{FDC5BF04-28D9-4B06-A8F3-DEC669F7CDC1}" dt="2026-06-02T02:24:20.008" v="112" actId="207"/>
-          <ac:spMkLst>
-            <pc:docMk/>
-            <pc:sldMk cId="0" sldId="256"/>
-            <ac:spMk id="44" creationId="{00000000-0000-0000-0000-000000000000}"/>
-          </ac:spMkLst>
-        </pc:spChg>
-        <pc:spChg chg="del">
-          <ac:chgData name="Yofadikara Nurrohman" userId="92e6fe32f2f0c507" providerId="LiveId" clId="{FDC5BF04-28D9-4B06-A8F3-DEC669F7CDC1}" dt="2026-06-02T02:22:24.073" v="66" actId="478"/>
-          <ac:spMkLst>
-            <pc:docMk/>
-            <pc:sldMk cId="0" sldId="256"/>
-            <ac:spMk id="47" creationId="{00000000-0000-0000-0000-000000000000}"/>
-          </ac:spMkLst>
-        </pc:spChg>
-        <pc:spChg chg="mod">
-          <ac:chgData name="Yofadikara Nurrohman" userId="92e6fe32f2f0c507" providerId="LiveId" clId="{FDC5BF04-28D9-4B06-A8F3-DEC669F7CDC1}" dt="2026-06-02T02:25:57.300" v="138" actId="207"/>
-          <ac:spMkLst>
-            <pc:docMk/>
-            <pc:sldMk cId="0" sldId="256"/>
-            <ac:spMk id="55" creationId="{00000000-0000-0000-0000-000000000000}"/>
-          </ac:spMkLst>
-        </pc:spChg>
-        <pc:spChg chg="mod">
-          <ac:chgData name="Yofadikara Nurrohman" userId="92e6fe32f2f0c507" providerId="LiveId" clId="{FDC5BF04-28D9-4B06-A8F3-DEC669F7CDC1}" dt="2026-06-02T02:26:08.184" v="142" actId="207"/>
-          <ac:spMkLst>
-            <pc:docMk/>
-            <pc:sldMk cId="0" sldId="256"/>
-            <ac:spMk id="60" creationId="{00000000-0000-0000-0000-000000000000}"/>
-          </ac:spMkLst>
-        </pc:spChg>
-        <pc:spChg chg="mod">
-          <ac:chgData name="Yofadikara Nurrohman" userId="92e6fe32f2f0c507" providerId="LiveId" clId="{FDC5BF04-28D9-4B06-A8F3-DEC669F7CDC1}" dt="2026-06-02T02:26:06.100" v="141" actId="207"/>
-          <ac:spMkLst>
-            <pc:docMk/>
-            <pc:sldMk cId="0" sldId="256"/>
-            <ac:spMk id="61" creationId="{00000000-0000-0000-0000-000000000000}"/>
-          </ac:spMkLst>
-        </pc:spChg>
-        <pc:spChg chg="mod">
-          <ac:chgData name="Yofadikara Nurrohman" userId="92e6fe32f2f0c507" providerId="LiveId" clId="{FDC5BF04-28D9-4B06-A8F3-DEC669F7CDC1}" dt="2026-06-02T02:26:01.782" v="139" actId="207"/>
-          <ac:spMkLst>
-            <pc:docMk/>
-            <pc:sldMk cId="0" sldId="256"/>
-            <ac:spMk id="66" creationId="{00000000-0000-0000-0000-000000000000}"/>
-          </ac:spMkLst>
-        </pc:spChg>
-        <pc:spChg chg="mod">
-          <ac:chgData name="Yofadikara Nurrohman" userId="92e6fe32f2f0c507" providerId="LiveId" clId="{FDC5BF04-28D9-4B06-A8F3-DEC669F7CDC1}" dt="2026-06-02T02:26:10.710" v="143" actId="207"/>
-          <ac:spMkLst>
-            <pc:docMk/>
-            <pc:sldMk cId="0" sldId="256"/>
-            <ac:spMk id="72" creationId="{00000000-0000-0000-0000-000000000000}"/>
-          </ac:spMkLst>
-        </pc:spChg>
-        <pc:spChg chg="mod">
-          <ac:chgData name="Yofadikara Nurrohman" userId="92e6fe32f2f0c507" providerId="LiveId" clId="{FDC5BF04-28D9-4B06-A8F3-DEC669F7CDC1}" dt="2026-06-02T02:26:13.416" v="144" actId="207"/>
-          <ac:spMkLst>
-            <pc:docMk/>
-            <pc:sldMk cId="0" sldId="256"/>
-            <ac:spMk id="78" creationId="{00000000-0000-0000-0000-000000000000}"/>
-          </ac:spMkLst>
-        </pc:spChg>
-        <pc:spChg chg="mod">
-          <ac:chgData name="Yofadikara Nurrohman" userId="92e6fe32f2f0c507" providerId="LiveId" clId="{FDC5BF04-28D9-4B06-A8F3-DEC669F7CDC1}" dt="2026-06-02T02:26:18.294" v="146" actId="207"/>
-          <ac:spMkLst>
-            <pc:docMk/>
-            <pc:sldMk cId="0" sldId="256"/>
-            <ac:spMk id="84" creationId="{00000000-0000-0000-0000-000000000000}"/>
-          </ac:spMkLst>
-        </pc:spChg>
-        <pc:spChg chg="add mod">
-          <ac:chgData name="Yofadikara Nurrohman" userId="92e6fe32f2f0c507" providerId="LiveId" clId="{FDC5BF04-28D9-4B06-A8F3-DEC669F7CDC1}" dt="2026-06-02T02:22:31.807" v="69"/>
-          <ac:spMkLst>
-            <pc:docMk/>
-            <pc:sldMk cId="0" sldId="256"/>
-            <ac:spMk id="86" creationId="{F27914F6-5A2B-8714-ABF7-969E72355730}"/>
-          </ac:spMkLst>
-        </pc:spChg>
-        <pc:spChg chg="mod">
-          <ac:chgData name="Yofadikara Nurrohman" userId="92e6fe32f2f0c507" providerId="LiveId" clId="{FDC5BF04-28D9-4B06-A8F3-DEC669F7CDC1}" dt="2026-06-02T02:26:24.533" v="147" actId="207"/>
-          <ac:spMkLst>
-            <pc:docMk/>
-            <pc:sldMk cId="0" sldId="256"/>
-            <ac:spMk id="87" creationId="{00000000-0000-0000-0000-000000000000}"/>
-          </ac:spMkLst>
-        </pc:spChg>
-        <pc:spChg chg="mod">
-          <ac:chgData name="Yofadikara Nurrohman" userId="92e6fe32f2f0c507" providerId="LiveId" clId="{FDC5BF04-28D9-4B06-A8F3-DEC669F7CDC1}" dt="2026-06-02T02:26:27.136" v="148" actId="207"/>
-          <ac:spMkLst>
-            <pc:docMk/>
-            <pc:sldMk cId="0" sldId="256"/>
-            <ac:spMk id="90" creationId="{00000000-0000-0000-0000-000000000000}"/>
-          </ac:spMkLst>
-        </pc:spChg>
-        <pc:spChg chg="mod">
-          <ac:chgData name="Yofadikara Nurrohman" userId="92e6fe32f2f0c507" providerId="LiveId" clId="{FDC5BF04-28D9-4B06-A8F3-DEC669F7CDC1}" dt="2026-06-02T02:26:29.624" v="149" actId="207"/>
-          <ac:spMkLst>
-            <pc:docMk/>
-            <pc:sldMk cId="0" sldId="256"/>
-            <ac:spMk id="93" creationId="{00000000-0000-0000-0000-000000000000}"/>
-          </ac:spMkLst>
-        </pc:spChg>
-        <pc:spChg chg="mod">
-          <ac:chgData name="Yofadikara Nurrohman" userId="92e6fe32f2f0c507" providerId="LiveId" clId="{FDC5BF04-28D9-4B06-A8F3-DEC669F7CDC1}" dt="2026-06-02T02:26:32.047" v="150" actId="207"/>
-          <ac:spMkLst>
-            <pc:docMk/>
-            <pc:sldMk cId="0" sldId="256"/>
-            <ac:spMk id="96" creationId="{00000000-0000-0000-0000-000000000000}"/>
-          </ac:spMkLst>
-        </pc:spChg>
-        <pc:spChg chg="mod">
-          <ac:chgData name="Yofadikara Nurrohman" userId="92e6fe32f2f0c507" providerId="LiveId" clId="{FDC5BF04-28D9-4B06-A8F3-DEC669F7CDC1}" dt="2026-06-02T02:26:34.134" v="151" actId="207"/>
-          <ac:spMkLst>
-            <pc:docMk/>
-            <pc:sldMk cId="0" sldId="256"/>
-            <ac:spMk id="99" creationId="{00000000-0000-0000-0000-000000000000}"/>
-          </ac:spMkLst>
-        </pc:spChg>
-        <pc:spChg chg="mod">
-          <ac:chgData name="Yofadikara Nurrohman" userId="92e6fe32f2f0c507" providerId="LiveId" clId="{FDC5BF04-28D9-4B06-A8F3-DEC669F7CDC1}" dt="2026-06-02T02:26:36.210" v="152" actId="207"/>
-          <ac:spMkLst>
-            <pc:docMk/>
-            <pc:sldMk cId="0" sldId="256"/>
-            <ac:spMk id="102" creationId="{00000000-0000-0000-0000-000000000000}"/>
-          </ac:spMkLst>
-        </pc:spChg>
-        <pc:spChg chg="mod">
-          <ac:chgData name="Yofadikara Nurrohman" userId="92e6fe32f2f0c507" providerId="LiveId" clId="{FDC5BF04-28D9-4B06-A8F3-DEC669F7CDC1}" dt="2026-06-02T02:26:39.346" v="153" actId="207"/>
-          <ac:spMkLst>
-            <pc:docMk/>
-            <pc:sldMk cId="0" sldId="256"/>
-            <ac:spMk id="105" creationId="{00000000-0000-0000-0000-000000000000}"/>
-          </ac:spMkLst>
-        </pc:spChg>
-        <pc:spChg chg="mod">
-          <ac:chgData name="Yofadikara Nurrohman" userId="92e6fe32f2f0c507" providerId="LiveId" clId="{FDC5BF04-28D9-4B06-A8F3-DEC669F7CDC1}" dt="2026-06-02T02:26:41.240" v="154" actId="207"/>
-          <ac:spMkLst>
-            <pc:docMk/>
-            <pc:sldMk cId="0" sldId="256"/>
-            <ac:spMk id="108" creationId="{00000000-0000-0000-0000-000000000000}"/>
-          </ac:spMkLst>
-        </pc:spChg>
-        <pc:spChg chg="mod">
-          <ac:chgData name="Yofadikara Nurrohman" userId="92e6fe32f2f0c507" providerId="LiveId" clId="{FDC5BF04-28D9-4B06-A8F3-DEC669F7CDC1}" dt="2026-06-02T02:27:05.362" v="160" actId="207"/>
-          <ac:spMkLst>
-            <pc:docMk/>
-            <pc:sldMk cId="0" sldId="256"/>
-            <ac:spMk id="111" creationId="{00000000-0000-0000-0000-000000000000}"/>
-          </ac:spMkLst>
-        </pc:spChg>
-        <pc:spChg chg="mod">
-          <ac:chgData name="Yofadikara Nurrohman" userId="92e6fe32f2f0c507" providerId="LiveId" clId="{FDC5BF04-28D9-4B06-A8F3-DEC669F7CDC1}" dt="2026-06-02T02:27:07.688" v="161" actId="207"/>
-          <ac:spMkLst>
-            <pc:docMk/>
-            <pc:sldMk cId="0" sldId="256"/>
-            <ac:spMk id="114" creationId="{00000000-0000-0000-0000-000000000000}"/>
-          </ac:spMkLst>
-        </pc:spChg>
-        <pc:spChg chg="mod">
-          <ac:chgData name="Yofadikara Nurrohman" userId="92e6fe32f2f0c507" providerId="LiveId" clId="{FDC5BF04-28D9-4B06-A8F3-DEC669F7CDC1}" dt="2026-06-02T02:26:49.582" v="157" actId="207"/>
-          <ac:spMkLst>
-            <pc:docMk/>
-            <pc:sldMk cId="0" sldId="256"/>
-            <ac:spMk id="117" creationId="{00000000-0000-0000-0000-000000000000}"/>
-          </ac:spMkLst>
-        </pc:spChg>
-        <pc:spChg chg="mod">
-          <ac:chgData name="Yofadikara Nurrohman" userId="92e6fe32f2f0c507" providerId="LiveId" clId="{FDC5BF04-28D9-4B06-A8F3-DEC669F7CDC1}" dt="2026-06-02T02:26:44.801" v="156" actId="207"/>
-          <ac:spMkLst>
-            <pc:docMk/>
-            <pc:sldMk cId="0" sldId="256"/>
-            <ac:spMk id="118" creationId="{00000000-0000-0000-0000-000000000000}"/>
-          </ac:spMkLst>
-        </pc:spChg>
-        <pc:spChg chg="mod">
-          <ac:chgData name="Yofadikara Nurrohman" userId="92e6fe32f2f0c507" providerId="LiveId" clId="{FDC5BF04-28D9-4B06-A8F3-DEC669F7CDC1}" dt="2026-06-02T02:27:34.744" v="168" actId="207"/>
-          <ac:spMkLst>
-            <pc:docMk/>
-            <pc:sldMk cId="0" sldId="256"/>
-            <ac:spMk id="120" creationId="{00000000-0000-0000-0000-000000000000}"/>
-          </ac:spMkLst>
-        </pc:spChg>
-        <pc:spChg chg="mod">
-          <ac:chgData name="Yofadikara Nurrohman" userId="92e6fe32f2f0c507" providerId="LiveId" clId="{FDC5BF04-28D9-4B06-A8F3-DEC669F7CDC1}" dt="2026-06-02T02:27:32.004" v="167" actId="207"/>
-          <ac:spMkLst>
-            <pc:docMk/>
-            <pc:sldMk cId="0" sldId="256"/>
-            <ac:spMk id="121" creationId="{00000000-0000-0000-0000-000000000000}"/>
-          </ac:spMkLst>
-        </pc:spChg>
-        <pc:spChg chg="mod">
-          <ac:chgData name="Yofadikara Nurrohman" userId="92e6fe32f2f0c507" providerId="LiveId" clId="{FDC5BF04-28D9-4B06-A8F3-DEC669F7CDC1}" dt="2026-06-02T02:27:36.853" v="169" actId="207"/>
-          <ac:spMkLst>
-            <pc:docMk/>
-            <pc:sldMk cId="0" sldId="256"/>
-            <ac:spMk id="123" creationId="{00000000-0000-0000-0000-000000000000}"/>
-          </ac:spMkLst>
-        </pc:spChg>
-        <pc:spChg chg="mod">
-          <ac:chgData name="Yofadikara Nurrohman" userId="92e6fe32f2f0c507" providerId="LiveId" clId="{FDC5BF04-28D9-4B06-A8F3-DEC669F7CDC1}" dt="2026-06-02T02:26:52.267" v="158" actId="207"/>
-          <ac:spMkLst>
-            <pc:docMk/>
-            <pc:sldMk cId="0" sldId="256"/>
-            <ac:spMk id="126" creationId="{00000000-0000-0000-0000-000000000000}"/>
-          </ac:spMkLst>
-        </pc:spChg>
-        <pc:spChg chg="mod">
-          <ac:chgData name="Yofadikara Nurrohman" userId="92e6fe32f2f0c507" providerId="LiveId" clId="{FDC5BF04-28D9-4B06-A8F3-DEC669F7CDC1}" dt="2026-06-02T02:27:01.110" v="159" actId="207"/>
-          <ac:spMkLst>
-            <pc:docMk/>
-            <pc:sldMk cId="0" sldId="256"/>
-            <ac:spMk id="129" creationId="{00000000-0000-0000-0000-000000000000}"/>
-          </ac:spMkLst>
-        </pc:spChg>
-        <pc:spChg chg="mod">
-          <ac:chgData name="Yofadikara Nurrohman" userId="92e6fe32f2f0c507" providerId="LiveId" clId="{FDC5BF04-28D9-4B06-A8F3-DEC669F7CDC1}" dt="2026-06-02T02:27:16.065" v="163" actId="207"/>
-          <ac:spMkLst>
-            <pc:docMk/>
-            <pc:sldMk cId="0" sldId="256"/>
-            <ac:spMk id="132" creationId="{00000000-0000-0000-0000-000000000000}"/>
-          </ac:spMkLst>
-        </pc:spChg>
-        <pc:spChg chg="mod">
-          <ac:chgData name="Yofadikara Nurrohman" userId="92e6fe32f2f0c507" providerId="LiveId" clId="{FDC5BF04-28D9-4B06-A8F3-DEC669F7CDC1}" dt="2026-06-02T02:27:21.908" v="164" actId="207"/>
-          <ac:spMkLst>
-            <pc:docMk/>
-            <pc:sldMk cId="0" sldId="256"/>
-            <ac:spMk id="135" creationId="{00000000-0000-0000-0000-000000000000}"/>
-          </ac:spMkLst>
-        </pc:spChg>
-        <pc:spChg chg="mod">
-          <ac:chgData name="Yofadikara Nurrohman" userId="92e6fe32f2f0c507" providerId="LiveId" clId="{FDC5BF04-28D9-4B06-A8F3-DEC669F7CDC1}" dt="2026-06-02T02:27:26.820" v="165" actId="207"/>
-          <ac:spMkLst>
-            <pc:docMk/>
-            <pc:sldMk cId="0" sldId="256"/>
-            <ac:spMk id="138" creationId="{00000000-0000-0000-0000-000000000000}"/>
-          </ac:spMkLst>
-        </pc:spChg>
-        <pc:spChg chg="mod">
-          <ac:chgData name="Yofadikara Nurrohman" userId="92e6fe32f2f0c507" providerId="LiveId" clId="{FDC5BF04-28D9-4B06-A8F3-DEC669F7CDC1}" dt="2026-06-02T02:27:39.124" v="170" actId="207"/>
-          <ac:spMkLst>
-            <pc:docMk/>
-            <pc:sldMk cId="0" sldId="256"/>
-            <ac:spMk id="145" creationId="{00000000-0000-0000-0000-000000000000}"/>
-          </ac:spMkLst>
-        </pc:spChg>
-        <pc:spChg chg="mod">
-          <ac:chgData name="Yofadikara Nurrohman" userId="92e6fe32f2f0c507" providerId="LiveId" clId="{FDC5BF04-28D9-4B06-A8F3-DEC669F7CDC1}" dt="2026-06-02T02:27:41.554" v="171" actId="207"/>
-          <ac:spMkLst>
-            <pc:docMk/>
-            <pc:sldMk cId="0" sldId="256"/>
-            <ac:spMk id="149" creationId="{00000000-0000-0000-0000-000000000000}"/>
-          </ac:spMkLst>
-        </pc:spChg>
-        <pc:spChg chg="mod">
-          <ac:chgData name="Yofadikara Nurrohman" userId="92e6fe32f2f0c507" providerId="LiveId" clId="{FDC5BF04-28D9-4B06-A8F3-DEC669F7CDC1}" dt="2026-06-02T02:27:48.315" v="172" actId="207"/>
-          <ac:spMkLst>
-            <pc:docMk/>
-            <pc:sldMk cId="0" sldId="256"/>
-            <ac:spMk id="152" creationId="{00000000-0000-0000-0000-000000000000}"/>
-          </ac:spMkLst>
-        </pc:spChg>
-        <pc:spChg chg="mod">
-          <ac:chgData name="Yofadikara Nurrohman" userId="92e6fe32f2f0c507" providerId="LiveId" clId="{FDC5BF04-28D9-4B06-A8F3-DEC669F7CDC1}" dt="2026-06-02T02:27:11.669" v="162" actId="207"/>
-          <ac:spMkLst>
-            <pc:docMk/>
-            <pc:sldMk cId="0" sldId="256"/>
-            <ac:spMk id="155" creationId="{00000000-0000-0000-0000-000000000000}"/>
-          </ac:spMkLst>
-        </pc:spChg>
-        <pc:spChg chg="mod topLvl">
-          <ac:chgData name="Yofadikara Nurrohman" userId="92e6fe32f2f0c507" providerId="LiveId" clId="{FDC5BF04-28D9-4B06-A8F3-DEC669F7CDC1}" dt="2026-06-02T02:32:55.049" v="209" actId="478"/>
-          <ac:spMkLst>
-            <pc:docMk/>
-            <pc:sldMk cId="0" sldId="256"/>
-            <ac:spMk id="158" creationId="{00000000-0000-0000-0000-000000000000}"/>
-          </ac:spMkLst>
-        </pc:spChg>
-        <pc:spChg chg="del mod topLvl">
-          <ac:chgData name="Yofadikara Nurrohman" userId="92e6fe32f2f0c507" providerId="LiveId" clId="{FDC5BF04-28D9-4B06-A8F3-DEC669F7CDC1}" dt="2026-06-02T02:32:55.049" v="209" actId="478"/>
-          <ac:spMkLst>
-            <pc:docMk/>
-            <pc:sldMk cId="0" sldId="256"/>
-            <ac:spMk id="159" creationId="{00000000-0000-0000-0000-000000000000}"/>
-          </ac:spMkLst>
-        </pc:spChg>
-        <pc:spChg chg="mod">
-          <ac:chgData name="Yofadikara Nurrohman" userId="92e6fe32f2f0c507" providerId="LiveId" clId="{FDC5BF04-28D9-4B06-A8F3-DEC669F7CDC1}" dt="2026-06-02T02:25:41.362" v="134" actId="207"/>
-          <ac:spMkLst>
-            <pc:docMk/>
-            <pc:sldMk cId="0" sldId="256"/>
-            <ac:spMk id="161" creationId="{00000000-0000-0000-0000-000000000000}"/>
-          </ac:spMkLst>
-        </pc:spChg>
-        <pc:spChg chg="mod">
-          <ac:chgData name="Yofadikara Nurrohman" userId="92e6fe32f2f0c507" providerId="LiveId" clId="{FDC5BF04-28D9-4B06-A8F3-DEC669F7CDC1}" dt="2026-06-02T02:25:32.771" v="131" actId="207"/>
-          <ac:spMkLst>
-            <pc:docMk/>
-            <pc:sldMk cId="0" sldId="256"/>
-            <ac:spMk id="162" creationId="{00000000-0000-0000-0000-000000000000}"/>
-          </ac:spMkLst>
-        </pc:spChg>
-        <pc:spChg chg="mod">
-          <ac:chgData name="Yofadikara Nurrohman" userId="92e6fe32f2f0c507" providerId="LiveId" clId="{FDC5BF04-28D9-4B06-A8F3-DEC669F7CDC1}" dt="2026-06-02T02:25:45.216" v="135" actId="207"/>
-          <ac:spMkLst>
-            <pc:docMk/>
-            <pc:sldMk cId="0" sldId="256"/>
-            <ac:spMk id="171" creationId="{00000000-0000-0000-0000-000000000000}"/>
-          </ac:spMkLst>
-        </pc:spChg>
-        <pc:spChg chg="mod">
-          <ac:chgData name="Yofadikara Nurrohman" userId="92e6fe32f2f0c507" providerId="LiveId" clId="{FDC5BF04-28D9-4B06-A8F3-DEC669F7CDC1}" dt="2026-06-02T02:25:38.469" v="133" actId="207"/>
-          <ac:spMkLst>
-            <pc:docMk/>
-            <pc:sldMk cId="0" sldId="256"/>
-            <ac:spMk id="181" creationId="{00000000-0000-0000-0000-000000000000}"/>
-          </ac:spMkLst>
-        </pc:spChg>
-        <pc:spChg chg="mod">
-          <ac:chgData name="Yofadikara Nurrohman" userId="92e6fe32f2f0c507" providerId="LiveId" clId="{FDC5BF04-28D9-4B06-A8F3-DEC669F7CDC1}" dt="2026-06-02T02:25:03.288" v="124" actId="207"/>
-          <ac:spMkLst>
-            <pc:docMk/>
-            <pc:sldMk cId="0" sldId="256"/>
-            <ac:spMk id="182" creationId="{00000000-0000-0000-0000-000000000000}"/>
-          </ac:spMkLst>
-        </pc:spChg>
-        <pc:spChg chg="mod">
-          <ac:chgData name="Yofadikara Nurrohman" userId="92e6fe32f2f0c507" providerId="LiveId" clId="{FDC5BF04-28D9-4B06-A8F3-DEC669F7CDC1}" dt="2026-06-02T02:25:49.328" v="136" actId="207"/>
-          <ac:spMkLst>
-            <pc:docMk/>
-            <pc:sldMk cId="0" sldId="256"/>
-            <ac:spMk id="191" creationId="{00000000-0000-0000-0000-000000000000}"/>
-          </ac:spMkLst>
-        </pc:spChg>
-        <pc:spChg chg="mod">
-          <ac:chgData name="Yofadikara Nurrohman" userId="92e6fe32f2f0c507" providerId="LiveId" clId="{FDC5BF04-28D9-4B06-A8F3-DEC669F7CDC1}" dt="2026-06-02T02:25:27.091" v="127" actId="207"/>
-          <ac:spMkLst>
-            <pc:docMk/>
-            <pc:sldMk cId="0" sldId="256"/>
-            <ac:spMk id="192" creationId="{00000000-0000-0000-0000-000000000000}"/>
-          </ac:spMkLst>
-        </pc:spChg>
-        <pc:spChg chg="add del mod topLvl">
-          <ac:chgData name="Yofadikara Nurrohman" userId="92e6fe32f2f0c507" providerId="LiveId" clId="{FDC5BF04-28D9-4B06-A8F3-DEC669F7CDC1}" dt="2026-06-02T02:32:45.883" v="208" actId="478"/>
-          <ac:spMkLst>
-            <pc:docMk/>
-            <pc:sldMk cId="0" sldId="256"/>
-            <ac:spMk id="202" creationId="{00000000-0000-0000-0000-000000000000}"/>
-          </ac:spMkLst>
-        </pc:spChg>
-        <pc:spChg chg="del mod topLvl">
-          <ac:chgData name="Yofadikara Nurrohman" userId="92e6fe32f2f0c507" providerId="LiveId" clId="{FDC5BF04-28D9-4B06-A8F3-DEC669F7CDC1}" dt="2026-06-02T02:32:45.883" v="208" actId="478"/>
-          <ac:spMkLst>
-            <pc:docMk/>
-            <pc:sldMk cId="0" sldId="256"/>
-            <ac:spMk id="203" creationId="{00000000-0000-0000-0000-000000000000}"/>
-          </ac:spMkLst>
-        </pc:spChg>
-        <pc:spChg chg="mod">
-          <ac:chgData name="Yofadikara Nurrohman" userId="92e6fe32f2f0c507" providerId="LiveId" clId="{FDC5BF04-28D9-4B06-A8F3-DEC669F7CDC1}" dt="2026-06-02T02:24:45.910" v="119" actId="207"/>
-          <ac:spMkLst>
-            <pc:docMk/>
-            <pc:sldMk cId="0" sldId="256"/>
-            <ac:spMk id="211" creationId="{00000000-0000-0000-0000-000000000000}"/>
-          </ac:spMkLst>
-        </pc:spChg>
-        <pc:spChg chg="mod">
-          <ac:chgData name="Yofadikara Nurrohman" userId="92e6fe32f2f0c507" providerId="LiveId" clId="{FDC5BF04-28D9-4B06-A8F3-DEC669F7CDC1}" dt="2026-06-02T02:24:49.109" v="120" actId="207"/>
-          <ac:spMkLst>
-            <pc:docMk/>
-            <pc:sldMk cId="0" sldId="256"/>
-            <ac:spMk id="213" creationId="{00000000-0000-0000-0000-000000000000}"/>
-          </ac:spMkLst>
-        </pc:spChg>
-        <pc:spChg chg="mod">
-          <ac:chgData name="Yofadikara Nurrohman" userId="92e6fe32f2f0c507" providerId="LiveId" clId="{FDC5BF04-28D9-4B06-A8F3-DEC669F7CDC1}" dt="2026-06-02T02:24:51.083" v="121" actId="207"/>
-          <ac:spMkLst>
-            <pc:docMk/>
-            <pc:sldMk cId="0" sldId="256"/>
-            <ac:spMk id="215" creationId="{00000000-0000-0000-0000-000000000000}"/>
-          </ac:spMkLst>
-        </pc:spChg>
-        <pc:spChg chg="mod">
-          <ac:chgData name="Yofadikara Nurrohman" userId="92e6fe32f2f0c507" providerId="LiveId" clId="{FDC5BF04-28D9-4B06-A8F3-DEC669F7CDC1}" dt="2026-06-02T02:24:53.815" v="122" actId="207"/>
-          <ac:spMkLst>
-            <pc:docMk/>
-            <pc:sldMk cId="0" sldId="256"/>
-            <ac:spMk id="217" creationId="{00000000-0000-0000-0000-000000000000}"/>
-          </ac:spMkLst>
-        </pc:spChg>
-        <pc:spChg chg="mod">
-          <ac:chgData name="Yofadikara Nurrohman" userId="92e6fe32f2f0c507" providerId="LiveId" clId="{FDC5BF04-28D9-4B06-A8F3-DEC669F7CDC1}" dt="2026-06-02T08:52:47.993" v="221" actId="207"/>
-          <ac:spMkLst>
-            <pc:docMk/>
-            <pc:sldMk cId="0" sldId="256"/>
-            <ac:spMk id="231" creationId="{00000000-0000-0000-0000-000000000000}"/>
-          </ac:spMkLst>
-        </pc:spChg>
-        <pc:spChg chg="mod">
-          <ac:chgData name="Yofadikara Nurrohman" userId="92e6fe32f2f0c507" providerId="LiveId" clId="{FDC5BF04-28D9-4B06-A8F3-DEC669F7CDC1}" dt="2026-06-02T02:30:47.336" v="181" actId="207"/>
-          <ac:spMkLst>
-            <pc:docMk/>
-            <pc:sldMk cId="0" sldId="256"/>
-            <ac:spMk id="239" creationId="{00000000-0000-0000-0000-000000000000}"/>
-          </ac:spMkLst>
-        </pc:spChg>
-        <pc:spChg chg="mod">
-          <ac:chgData name="Yofadikara Nurrohman" userId="92e6fe32f2f0c507" providerId="LiveId" clId="{FDC5BF04-28D9-4B06-A8F3-DEC669F7CDC1}" dt="2026-06-02T02:30:50.614" v="182" actId="207"/>
-          <ac:spMkLst>
-            <pc:docMk/>
-            <pc:sldMk cId="0" sldId="256"/>
-            <ac:spMk id="242" creationId="{00000000-0000-0000-0000-000000000000}"/>
-          </ac:spMkLst>
-        </pc:spChg>
-        <pc:spChg chg="mod">
-          <ac:chgData name="Yofadikara Nurrohman" userId="92e6fe32f2f0c507" providerId="LiveId" clId="{FDC5BF04-28D9-4B06-A8F3-DEC669F7CDC1}" dt="2026-06-02T02:30:53.161" v="183" actId="207"/>
-          <ac:spMkLst>
-            <pc:docMk/>
-            <pc:sldMk cId="0" sldId="256"/>
-            <ac:spMk id="243" creationId="{00000000-0000-0000-0000-000000000000}"/>
-          </ac:spMkLst>
-        </pc:spChg>
-        <pc:spChg chg="mod">
-          <ac:chgData name="Yofadikara Nurrohman" userId="92e6fe32f2f0c507" providerId="LiveId" clId="{FDC5BF04-28D9-4B06-A8F3-DEC669F7CDC1}" dt="2026-06-02T02:30:55.627" v="184" actId="207"/>
-          <ac:spMkLst>
-            <pc:docMk/>
-            <pc:sldMk cId="0" sldId="256"/>
-            <ac:spMk id="246" creationId="{00000000-0000-0000-0000-000000000000}"/>
-          </ac:spMkLst>
-        </pc:spChg>
-        <pc:spChg chg="mod">
-          <ac:chgData name="Yofadikara Nurrohman" userId="92e6fe32f2f0c507" providerId="LiveId" clId="{FDC5BF04-28D9-4B06-A8F3-DEC669F7CDC1}" dt="2026-06-02T02:31:58.713" v="195" actId="207"/>
-          <ac:spMkLst>
-            <pc:docMk/>
-            <pc:sldMk cId="0" sldId="256"/>
-            <ac:spMk id="249" creationId="{00000000-0000-0000-0000-000000000000}"/>
-          </ac:spMkLst>
-        </pc:spChg>
-        <pc:spChg chg="mod">
-          <ac:chgData name="Yofadikara Nurrohman" userId="92e6fe32f2f0c507" providerId="LiveId" clId="{FDC5BF04-28D9-4B06-A8F3-DEC669F7CDC1}" dt="2026-06-02T02:31:59.450" v="196" actId="207"/>
-          <ac:spMkLst>
-            <pc:docMk/>
-            <pc:sldMk cId="0" sldId="256"/>
-            <ac:spMk id="252" creationId="{00000000-0000-0000-0000-000000000000}"/>
-          </ac:spMkLst>
-        </pc:spChg>
-        <pc:spChg chg="ord">
-          <ac:chgData name="Yofadikara Nurrohman" userId="92e6fe32f2f0c507" providerId="LiveId" clId="{FDC5BF04-28D9-4B06-A8F3-DEC669F7CDC1}" dt="2026-06-02T02:21:25.560" v="54" actId="166"/>
-          <ac:spMkLst>
-            <pc:docMk/>
-            <pc:sldMk cId="0" sldId="256"/>
-            <ac:spMk id="303" creationId="{37F2C7E8-D9D4-63C4-4334-A2999CC05A1C}"/>
-          </ac:spMkLst>
-        </pc:spChg>
-        <pc:spChg chg="ord">
-          <ac:chgData name="Yofadikara Nurrohman" userId="92e6fe32f2f0c507" providerId="LiveId" clId="{FDC5BF04-28D9-4B06-A8F3-DEC669F7CDC1}" dt="2026-06-02T02:21:32.736" v="55" actId="166"/>
-          <ac:spMkLst>
-            <pc:docMk/>
-            <pc:sldMk cId="0" sldId="256"/>
-            <ac:spMk id="304" creationId="{5F94D436-B8CD-FF1D-2A87-399F8DF479EA}"/>
-          </ac:spMkLst>
-        </pc:spChg>
-        <pc:spChg chg="ord">
-          <ac:chgData name="Yofadikara Nurrohman" userId="92e6fe32f2f0c507" providerId="LiveId" clId="{FDC5BF04-28D9-4B06-A8F3-DEC669F7CDC1}" dt="2026-06-02T02:23:44.741" v="94" actId="166"/>
-          <ac:spMkLst>
-            <pc:docMk/>
-            <pc:sldMk cId="0" sldId="256"/>
-            <ac:spMk id="309" creationId="{352ECA08-E718-7A70-E230-E93BF92302BB}"/>
-          </ac:spMkLst>
-        </pc:spChg>
-        <pc:spChg chg="ord">
-          <ac:chgData name="Yofadikara Nurrohman" userId="92e6fe32f2f0c507" providerId="LiveId" clId="{FDC5BF04-28D9-4B06-A8F3-DEC669F7CDC1}" dt="2026-06-02T02:23:53.261" v="105" actId="166"/>
-          <ac:spMkLst>
-            <pc:docMk/>
-            <pc:sldMk cId="0" sldId="256"/>
-            <ac:spMk id="310" creationId="{00FB5F42-F8DF-6263-275E-2DA61D8EFC7B}"/>
-          </ac:spMkLst>
-        </pc:spChg>
-        <pc:spChg chg="mod">
-          <ac:chgData name="Yofadikara Nurrohman" userId="92e6fe32f2f0c507" providerId="LiveId" clId="{FDC5BF04-28D9-4B06-A8F3-DEC669F7CDC1}" dt="2026-06-02T02:33:12.964" v="210" actId="207"/>
-          <ac:spMkLst>
-            <pc:docMk/>
-            <pc:sldMk cId="0" sldId="256"/>
-            <ac:spMk id="313" creationId="{8C9B382D-36FD-F5C3-9341-842EF54ED96A}"/>
-          </ac:spMkLst>
-        </pc:spChg>
-        <pc:spChg chg="mod">
-          <ac:chgData name="Yofadikara Nurrohman" userId="92e6fe32f2f0c507" providerId="LiveId" clId="{FDC5BF04-28D9-4B06-A8F3-DEC669F7CDC1}" dt="2026-06-02T02:33:16.390" v="211" actId="207"/>
-          <ac:spMkLst>
-            <pc:docMk/>
-            <pc:sldMk cId="0" sldId="256"/>
-            <ac:spMk id="314" creationId="{79211DC1-E6C8-5674-D9BA-B9C5579804BA}"/>
-          </ac:spMkLst>
-        </pc:spChg>
-        <pc:spChg chg="mod">
-          <ac:chgData name="Yofadikara Nurrohman" userId="92e6fe32f2f0c507" providerId="LiveId" clId="{FDC5BF04-28D9-4B06-A8F3-DEC669F7CDC1}" dt="2026-06-02T02:33:19.226" v="212" actId="207"/>
-          <ac:spMkLst>
-            <pc:docMk/>
-            <pc:sldMk cId="0" sldId="256"/>
-            <ac:spMk id="315" creationId="{C66E4244-10D6-10FF-A300-A17CE7ED333F}"/>
-          </ac:spMkLst>
-        </pc:spChg>
-        <pc:spChg chg="mod">
-          <ac:chgData name="Yofadikara Nurrohman" userId="92e6fe32f2f0c507" providerId="LiveId" clId="{FDC5BF04-28D9-4B06-A8F3-DEC669F7CDC1}" dt="2026-06-02T02:33:43.237" v="217" actId="207"/>
-          <ac:spMkLst>
-            <pc:docMk/>
-            <pc:sldMk cId="0" sldId="256"/>
-            <ac:spMk id="327" creationId="{1E01DE9A-2B35-B73E-B878-FDE9F82CE4DE}"/>
-          </ac:spMkLst>
-        </pc:spChg>
-        <pc:spChg chg="mod">
-          <ac:chgData name="Yofadikara Nurrohman" userId="92e6fe32f2f0c507" providerId="LiveId" clId="{FDC5BF04-28D9-4B06-A8F3-DEC669F7CDC1}" dt="2026-06-02T02:33:40.571" v="216" actId="207"/>
-          <ac:spMkLst>
-            <pc:docMk/>
-            <pc:sldMk cId="0" sldId="256"/>
-            <ac:spMk id="328" creationId="{5490F4D4-A250-4119-7E34-1626A07BCB92}"/>
-          </ac:spMkLst>
-        </pc:spChg>
-        <pc:spChg chg="mod">
-          <ac:chgData name="Yofadikara Nurrohman" userId="92e6fe32f2f0c507" providerId="LiveId" clId="{FDC5BF04-28D9-4B06-A8F3-DEC669F7CDC1}" dt="2026-06-02T02:33:37.515" v="215" actId="207"/>
-          <ac:spMkLst>
-            <pc:docMk/>
-            <pc:sldMk cId="0" sldId="256"/>
-            <ac:spMk id="329" creationId="{40930771-BD2C-ECCB-F4A1-23A69B10DDC6}"/>
-          </ac:spMkLst>
-        </pc:spChg>
-        <pc:spChg chg="mod">
-          <ac:chgData name="Yofadikara Nurrohman" userId="92e6fe32f2f0c507" providerId="LiveId" clId="{FDC5BF04-28D9-4B06-A8F3-DEC669F7CDC1}" dt="2026-06-02T02:33:35.236" v="214" actId="207"/>
-          <ac:spMkLst>
-            <pc:docMk/>
-            <pc:sldMk cId="0" sldId="256"/>
-            <ac:spMk id="330" creationId="{6E88D595-5ED0-827A-6E36-D81A7320CD5D}"/>
-          </ac:spMkLst>
-        </pc:spChg>
-        <pc:spChg chg="mod">
-          <ac:chgData name="Yofadikara Nurrohman" userId="92e6fe32f2f0c507" providerId="LiveId" clId="{FDC5BF04-28D9-4B06-A8F3-DEC669F7CDC1}" dt="2026-06-02T02:33:30.017" v="213" actId="207"/>
-          <ac:spMkLst>
-            <pc:docMk/>
-            <pc:sldMk cId="0" sldId="256"/>
-            <ac:spMk id="331" creationId="{C8CE0CAC-3756-D9CA-5583-CAEABF186F77}"/>
-          </ac:spMkLst>
-        </pc:spChg>
-        <pc:spChg chg="mod">
-          <ac:chgData name="Yofadikara Nurrohman" userId="92e6fe32f2f0c507" providerId="LiveId" clId="{FDC5BF04-28D9-4B06-A8F3-DEC669F7CDC1}" dt="2026-06-02T08:52:43.564" v="220" actId="207"/>
+          <ac:chgData name="Yofadikara Nurrohman" userId="92e6fe32f2f0c507" providerId="LiveId" clId="{FDC5BF04-28D9-4B06-A8F3-DEC669F7CDC1}" dt="2026-09-17T02:17:02.284" v="223" actId="14100"/>
           <ac:spMkLst>
             <pc:docMk/>
             <pc:sldMk cId="0" sldId="256"/>
             <ac:spMk id="380" creationId="{7AF20880-B62F-6E02-F706-DD1C37DF6DB1}"/>
           </ac:spMkLst>
         </pc:spChg>
-        <pc:grpChg chg="add del mod">
-          <ac:chgData name="Yofadikara Nurrohman" userId="92e6fe32f2f0c507" providerId="LiveId" clId="{FDC5BF04-28D9-4B06-A8F3-DEC669F7CDC1}" dt="2026-06-02T02:21:49.064" v="57" actId="478"/>
-          <ac:grpSpMkLst>
-            <pc:docMk/>
-            <pc:sldMk cId="0" sldId="256"/>
-            <ac:grpSpMk id="2" creationId="{CC776E43-B37E-FEEA-65BA-CE44246383C4}"/>
-          </ac:grpSpMkLst>
-        </pc:grpChg>
-        <pc:grpChg chg="mod">
-          <ac:chgData name="Yofadikara Nurrohman" userId="92e6fe32f2f0c507" providerId="LiveId" clId="{FDC5BF04-28D9-4B06-A8F3-DEC669F7CDC1}" dt="2026-06-02T02:31:52.164" v="189" actId="207"/>
-          <ac:grpSpMkLst>
-            <pc:docMk/>
-            <pc:sldMk cId="0" sldId="256"/>
-            <ac:grpSpMk id="16" creationId="{00000000-0000-0000-0000-000000000000}"/>
-          </ac:grpSpMkLst>
-        </pc:grpChg>
-        <pc:grpChg chg="mod">
-          <ac:chgData name="Yofadikara Nurrohman" userId="92e6fe32f2f0c507" providerId="LiveId" clId="{FDC5BF04-28D9-4B06-A8F3-DEC669F7CDC1}" dt="2026-06-02T02:25:54.816" v="137" actId="207"/>
-          <ac:grpSpMkLst>
-            <pc:docMk/>
-            <pc:sldMk cId="0" sldId="256"/>
-            <ac:grpSpMk id="19" creationId="{00000000-0000-0000-0000-000000000000}"/>
-          </ac:grpSpMkLst>
-        </pc:grpChg>
-        <pc:grpChg chg="del mod">
-          <ac:chgData name="Yofadikara Nurrohman" userId="92e6fe32f2f0c507" providerId="LiveId" clId="{FDC5BF04-28D9-4B06-A8F3-DEC669F7CDC1}" dt="2026-06-02T02:32:34.832" v="205" actId="478"/>
-          <ac:grpSpMkLst>
-            <pc:docMk/>
-            <pc:sldMk cId="0" sldId="256"/>
-            <ac:grpSpMk id="21" creationId="{00000000-0000-0000-0000-000000000000}"/>
-          </ac:grpSpMkLst>
-        </pc:grpChg>
-        <pc:grpChg chg="mod">
-          <ac:chgData name="Yofadikara Nurrohman" userId="92e6fe32f2f0c507" providerId="LiveId" clId="{FDC5BF04-28D9-4B06-A8F3-DEC669F7CDC1}" dt="2026-06-02T02:21:41.018" v="56" actId="207"/>
-          <ac:grpSpMkLst>
-            <pc:docMk/>
-            <pc:sldMk cId="0" sldId="256"/>
-            <ac:grpSpMk id="30" creationId="{00000000-0000-0000-0000-000000000000}"/>
-          </ac:grpSpMkLst>
-        </pc:grpChg>
-        <pc:grpChg chg="mod">
-          <ac:chgData name="Yofadikara Nurrohman" userId="92e6fe32f2f0c507" providerId="LiveId" clId="{FDC5BF04-28D9-4B06-A8F3-DEC669F7CDC1}" dt="2026-06-02T02:20:32.874" v="47" actId="207"/>
-          <ac:grpSpMkLst>
-            <pc:docMk/>
-            <pc:sldMk cId="0" sldId="256"/>
-            <ac:grpSpMk id="35" creationId="{00000000-0000-0000-0000-000000000000}"/>
-          </ac:grpSpMkLst>
-        </pc:grpChg>
-        <pc:grpChg chg="mod">
-          <ac:chgData name="Yofadikara Nurrohman" userId="92e6fe32f2f0c507" providerId="LiveId" clId="{FDC5BF04-28D9-4B06-A8F3-DEC669F7CDC1}" dt="2026-06-02T02:24:15.222" v="111" actId="207"/>
-          <ac:grpSpMkLst>
-            <pc:docMk/>
-            <pc:sldMk cId="0" sldId="256"/>
-            <ac:grpSpMk id="39" creationId="{00000000-0000-0000-0000-000000000000}"/>
-          </ac:grpSpMkLst>
-        </pc:grpChg>
-        <pc:grpChg chg="mod">
-          <ac:chgData name="Yofadikara Nurrohman" userId="92e6fe32f2f0c507" providerId="LiveId" clId="{FDC5BF04-28D9-4B06-A8F3-DEC669F7CDC1}" dt="2026-06-02T02:24:20.008" v="112" actId="207"/>
-          <ac:grpSpMkLst>
-            <pc:docMk/>
-            <pc:sldMk cId="0" sldId="256"/>
-            <ac:grpSpMk id="43" creationId="{00000000-0000-0000-0000-000000000000}"/>
-          </ac:grpSpMkLst>
-        </pc:grpChg>
-        <pc:grpChg chg="mod">
-          <ac:chgData name="Yofadikara Nurrohman" userId="92e6fe32f2f0c507" providerId="LiveId" clId="{FDC5BF04-28D9-4B06-A8F3-DEC669F7CDC1}" dt="2026-06-02T02:25:57.300" v="138" actId="207"/>
-          <ac:grpSpMkLst>
-            <pc:docMk/>
-            <pc:sldMk cId="0" sldId="256"/>
-            <ac:grpSpMk id="54" creationId="{00000000-0000-0000-0000-000000000000}"/>
-          </ac:grpSpMkLst>
-        </pc:grpChg>
-        <pc:grpChg chg="mod">
-          <ac:chgData name="Yofadikara Nurrohman" userId="92e6fe32f2f0c507" providerId="LiveId" clId="{FDC5BF04-28D9-4B06-A8F3-DEC669F7CDC1}" dt="2026-06-02T02:26:06.100" v="141" actId="207"/>
-          <ac:grpSpMkLst>
-            <pc:docMk/>
-            <pc:sldMk cId="0" sldId="256"/>
-            <ac:grpSpMk id="59" creationId="{00000000-0000-0000-0000-000000000000}"/>
-          </ac:grpSpMkLst>
-        </pc:grpChg>
-        <pc:grpChg chg="mod">
-          <ac:chgData name="Yofadikara Nurrohman" userId="92e6fe32f2f0c507" providerId="LiveId" clId="{FDC5BF04-28D9-4B06-A8F3-DEC669F7CDC1}" dt="2026-06-02T02:26:44.801" v="156" actId="207"/>
-          <ac:grpSpMkLst>
-            <pc:docMk/>
-            <pc:sldMk cId="0" sldId="256"/>
-            <ac:grpSpMk id="116" creationId="{00000000-0000-0000-0000-000000000000}"/>
-          </ac:grpSpMkLst>
-        </pc:grpChg>
-        <pc:grpChg chg="mod">
-          <ac:chgData name="Yofadikara Nurrohman" userId="92e6fe32f2f0c507" providerId="LiveId" clId="{FDC5BF04-28D9-4B06-A8F3-DEC669F7CDC1}" dt="2026-06-02T02:27:32.004" v="167" actId="207"/>
-          <ac:grpSpMkLst>
-            <pc:docMk/>
-            <pc:sldMk cId="0" sldId="256"/>
-            <ac:grpSpMk id="119" creationId="{00000000-0000-0000-0000-000000000000}"/>
-          </ac:grpSpMkLst>
-        </pc:grpChg>
-        <pc:grpChg chg="del">
-          <ac:chgData name="Yofadikara Nurrohman" userId="92e6fe32f2f0c507" providerId="LiveId" clId="{FDC5BF04-28D9-4B06-A8F3-DEC669F7CDC1}" dt="2026-06-02T02:32:55.049" v="209" actId="478"/>
-          <ac:grpSpMkLst>
-            <pc:docMk/>
-            <pc:sldMk cId="0" sldId="256"/>
-            <ac:grpSpMk id="157" creationId="{00000000-0000-0000-0000-000000000000}"/>
-          </ac:grpSpMkLst>
-        </pc:grpChg>
-        <pc:grpChg chg="mod">
-          <ac:chgData name="Yofadikara Nurrohman" userId="92e6fe32f2f0c507" providerId="LiveId" clId="{FDC5BF04-28D9-4B06-A8F3-DEC669F7CDC1}" dt="2026-06-02T02:25:32.771" v="131" actId="207"/>
-          <ac:grpSpMkLst>
-            <pc:docMk/>
-            <pc:sldMk cId="0" sldId="256"/>
-            <ac:grpSpMk id="160" creationId="{00000000-0000-0000-0000-000000000000}"/>
-          </ac:grpSpMkLst>
-        </pc:grpChg>
-        <pc:grpChg chg="mod">
-          <ac:chgData name="Yofadikara Nurrohman" userId="92e6fe32f2f0c507" providerId="LiveId" clId="{FDC5BF04-28D9-4B06-A8F3-DEC669F7CDC1}" dt="2026-06-02T02:25:03.288" v="124" actId="207"/>
-          <ac:grpSpMkLst>
-            <pc:docMk/>
-            <pc:sldMk cId="0" sldId="256"/>
-            <ac:grpSpMk id="180" creationId="{00000000-0000-0000-0000-000000000000}"/>
-          </ac:grpSpMkLst>
-        </pc:grpChg>
-        <pc:grpChg chg="mod">
-          <ac:chgData name="Yofadikara Nurrohman" userId="92e6fe32f2f0c507" providerId="LiveId" clId="{FDC5BF04-28D9-4B06-A8F3-DEC669F7CDC1}" dt="2026-06-02T02:25:27.091" v="127" actId="207"/>
-          <ac:grpSpMkLst>
-            <pc:docMk/>
-            <pc:sldMk cId="0" sldId="256"/>
-            <ac:grpSpMk id="190" creationId="{00000000-0000-0000-0000-000000000000}"/>
-          </ac:grpSpMkLst>
-        </pc:grpChg>
-        <pc:grpChg chg="add del">
-          <ac:chgData name="Yofadikara Nurrohman" userId="92e6fe32f2f0c507" providerId="LiveId" clId="{FDC5BF04-28D9-4B06-A8F3-DEC669F7CDC1}" dt="2026-06-02T02:32:45.883" v="208" actId="478"/>
-          <ac:grpSpMkLst>
-            <pc:docMk/>
-            <pc:sldMk cId="0" sldId="256"/>
-            <ac:grpSpMk id="201" creationId="{00000000-0000-0000-0000-000000000000}"/>
-          </ac:grpSpMkLst>
-        </pc:grpChg>
-        <pc:grpChg chg="mod">
-          <ac:chgData name="Yofadikara Nurrohman" userId="92e6fe32f2f0c507" providerId="LiveId" clId="{FDC5BF04-28D9-4B06-A8F3-DEC669F7CDC1}" dt="2026-06-02T02:24:45.910" v="119" actId="207"/>
-          <ac:grpSpMkLst>
-            <pc:docMk/>
-            <pc:sldMk cId="0" sldId="256"/>
-            <ac:grpSpMk id="210" creationId="{00000000-0000-0000-0000-000000000000}"/>
-          </ac:grpSpMkLst>
-        </pc:grpChg>
-        <pc:grpChg chg="mod">
-          <ac:chgData name="Yofadikara Nurrohman" userId="92e6fe32f2f0c507" providerId="LiveId" clId="{FDC5BF04-28D9-4B06-A8F3-DEC669F7CDC1}" dt="2026-06-02T02:24:49.109" v="120" actId="207"/>
-          <ac:grpSpMkLst>
-            <pc:docMk/>
-            <pc:sldMk cId="0" sldId="256"/>
-            <ac:grpSpMk id="212" creationId="{00000000-0000-0000-0000-000000000000}"/>
-          </ac:grpSpMkLst>
-        </pc:grpChg>
-        <pc:grpChg chg="mod">
-          <ac:chgData name="Yofadikara Nurrohman" userId="92e6fe32f2f0c507" providerId="LiveId" clId="{FDC5BF04-28D9-4B06-A8F3-DEC669F7CDC1}" dt="2026-06-02T02:24:51.083" v="121" actId="207"/>
-          <ac:grpSpMkLst>
-            <pc:docMk/>
-            <pc:sldMk cId="0" sldId="256"/>
-            <ac:grpSpMk id="214" creationId="{00000000-0000-0000-0000-000000000000}"/>
-          </ac:grpSpMkLst>
-        </pc:grpChg>
-        <pc:grpChg chg="mod">
-          <ac:chgData name="Yofadikara Nurrohman" userId="92e6fe32f2f0c507" providerId="LiveId" clId="{FDC5BF04-28D9-4B06-A8F3-DEC669F7CDC1}" dt="2026-06-02T02:24:53.815" v="122" actId="207"/>
-          <ac:grpSpMkLst>
-            <pc:docMk/>
-            <pc:sldMk cId="0" sldId="256"/>
-            <ac:grpSpMk id="216" creationId="{00000000-0000-0000-0000-000000000000}"/>
-          </ac:grpSpMkLst>
-        </pc:grpChg>
-        <pc:picChg chg="add del mod">
-          <ac:chgData name="Yofadikara Nurrohman" userId="92e6fe32f2f0c507" providerId="LiveId" clId="{FDC5BF04-28D9-4B06-A8F3-DEC669F7CDC1}" dt="2026-06-02T02:20:37.780" v="48" actId="478"/>
-          <ac:picMkLst>
-            <pc:docMk/>
-            <pc:sldMk cId="0" sldId="256"/>
-            <ac:picMk id="27" creationId="{00000000-0000-0000-0000-000000000000}"/>
-          </ac:picMkLst>
-        </pc:picChg>
-        <pc:picChg chg="add del">
-          <ac:chgData name="Yofadikara Nurrohman" userId="92e6fe32f2f0c507" providerId="LiveId" clId="{FDC5BF04-28D9-4B06-A8F3-DEC669F7CDC1}" dt="2026-06-02T02:22:23.439" v="65" actId="478"/>
-          <ac:picMkLst>
-            <pc:docMk/>
-            <pc:sldMk cId="0" sldId="256"/>
-            <ac:picMk id="28" creationId="{00000000-0000-0000-0000-000000000000}"/>
-          </ac:picMkLst>
-        </pc:picChg>
-        <pc:picChg chg="add mod">
-          <ac:chgData name="Yofadikara Nurrohman" userId="92e6fe32f2f0c507" providerId="LiveId" clId="{FDC5BF04-28D9-4B06-A8F3-DEC669F7CDC1}" dt="2026-06-02T02:18:13.157" v="11"/>
-          <ac:picMkLst>
-            <pc:docMk/>
-            <pc:sldMk cId="0" sldId="256"/>
-            <ac:picMk id="32" creationId="{62E19278-3373-E1C4-77EF-95842C55DC83}"/>
-          </ac:picMkLst>
-        </pc:picChg>
-        <pc:picChg chg="add mod ord">
-          <ac:chgData name="Yofadikara Nurrohman" userId="92e6fe32f2f0c507" providerId="LiveId" clId="{FDC5BF04-28D9-4B06-A8F3-DEC669F7CDC1}" dt="2026-06-02T02:18:34.934" v="20" actId="171"/>
-          <ac:picMkLst>
-            <pc:docMk/>
-            <pc:sldMk cId="0" sldId="256"/>
-            <ac:picMk id="34" creationId="{E71A2D14-7EDA-8CFC-F6FA-1F438DBA054C}"/>
-          </ac:picMkLst>
-        </pc:picChg>
-        <pc:picChg chg="add mod">
-          <ac:chgData name="Yofadikara Nurrohman" userId="92e6fe32f2f0c507" providerId="LiveId" clId="{FDC5BF04-28D9-4B06-A8F3-DEC669F7CDC1}" dt="2026-06-02T02:18:39.897" v="23"/>
-          <ac:picMkLst>
-            <pc:docMk/>
-            <pc:sldMk cId="0" sldId="256"/>
-            <ac:picMk id="37" creationId="{37F050E1-3CEF-C702-B486-CB99F7DF4497}"/>
-          </ac:picMkLst>
-        </pc:picChg>
-        <pc:picChg chg="add mod">
-          <ac:chgData name="Yofadikara Nurrohman" userId="92e6fe32f2f0c507" providerId="LiveId" clId="{FDC5BF04-28D9-4B06-A8F3-DEC669F7CDC1}" dt="2026-06-02T02:18:47.196" v="25"/>
-          <ac:picMkLst>
-            <pc:docMk/>
-            <pc:sldMk cId="0" sldId="256"/>
-            <ac:picMk id="41" creationId="{87D6193E-E571-3048-56DD-6D30FE2A8A52}"/>
-          </ac:picMkLst>
-        </pc:picChg>
-        <pc:picChg chg="add mod ord">
-          <ac:chgData name="Yofadikara Nurrohman" userId="92e6fe32f2f0c507" providerId="LiveId" clId="{FDC5BF04-28D9-4B06-A8F3-DEC669F7CDC1}" dt="2026-06-02T02:20:18.443" v="39" actId="171"/>
-          <ac:picMkLst>
-            <pc:docMk/>
-            <pc:sldMk cId="0" sldId="256"/>
-            <ac:picMk id="45" creationId="{365212E4-2F89-9CDF-2E4C-90CC33FCAC83}"/>
-          </ac:picMkLst>
-        </pc:picChg>
-        <pc:picChg chg="add mod">
-          <ac:chgData name="Yofadikara Nurrohman" userId="92e6fe32f2f0c507" providerId="LiveId" clId="{FDC5BF04-28D9-4B06-A8F3-DEC669F7CDC1}" dt="2026-06-02T02:20:41.058" v="49"/>
-          <ac:picMkLst>
-            <pc:docMk/>
-            <pc:sldMk cId="0" sldId="256"/>
-            <ac:picMk id="48" creationId="{268108F4-9FB8-977D-C509-B21716D56994}"/>
-          </ac:picMkLst>
-        </pc:picChg>
-        <pc:picChg chg="add mod">
-          <ac:chgData name="Yofadikara Nurrohman" userId="92e6fe32f2f0c507" providerId="LiveId" clId="{FDC5BF04-28D9-4B06-A8F3-DEC669F7CDC1}" dt="2026-06-02T02:21:19.785" v="53"/>
-          <ac:picMkLst>
-            <pc:docMk/>
-            <pc:sldMk cId="0" sldId="256"/>
-            <ac:picMk id="49" creationId="{B4A2CCA4-3803-A9FE-4ADF-592E2BD0E2C1}"/>
-          </ac:picMkLst>
-        </pc:picChg>
-        <pc:picChg chg="add mod ord">
-          <ac:chgData name="Yofadikara Nurrohman" userId="92e6fe32f2f0c507" providerId="LiveId" clId="{FDC5BF04-28D9-4B06-A8F3-DEC669F7CDC1}" dt="2026-06-02T02:22:10.818" v="63" actId="171"/>
-          <ac:picMkLst>
-            <pc:docMk/>
-            <pc:sldMk cId="0" sldId="256"/>
-            <ac:picMk id="52" creationId="{4376126A-978B-1D77-256C-569BB00810FB}"/>
-          </ac:picMkLst>
-        </pc:picChg>
-        <pc:picChg chg="add mod">
-          <ac:chgData name="Yofadikara Nurrohman" userId="92e6fe32f2f0c507" providerId="LiveId" clId="{FDC5BF04-28D9-4B06-A8F3-DEC669F7CDC1}" dt="2026-06-02T02:24:26.088" v="118" actId="1035"/>
-          <ac:picMkLst>
-            <pc:docMk/>
-            <pc:sldMk cId="0" sldId="256"/>
-            <ac:picMk id="53" creationId="{F7221D5C-6611-A7F3-BA4D-686FA6C5E269}"/>
-          </ac:picMkLst>
-        </pc:picChg>
-        <pc:picChg chg="add mod">
-          <ac:chgData name="Yofadikara Nurrohman" userId="92e6fe32f2f0c507" providerId="LiveId" clId="{FDC5BF04-28D9-4B06-A8F3-DEC669F7CDC1}" dt="2026-06-02T02:23:20.471" v="76" actId="571"/>
-          <ac:picMkLst>
-            <pc:docMk/>
-            <pc:sldMk cId="0" sldId="256"/>
-            <ac:picMk id="89" creationId="{A7784EEC-E6C7-D3D2-E328-4D7E5E8CFCCB}"/>
-          </ac:picMkLst>
-        </pc:picChg>
-      </pc:sldChg>
-    </pc:docChg>
-  </pc:docChgLst>
-  <pc:docChgLst>
-    <pc:chgData name="Yofadikara Nurrohman" userId="92e6fe32f2f0c507" providerId="LiveId" clId="{F3ACEA07-2EB0-4E77-91C0-0E26621468C2}"/>
-    <pc:docChg chg="undo custSel modSld">
-      <pc:chgData name="Yofadikara Nurrohman" userId="92e6fe32f2f0c507" providerId="LiveId" clId="{F3ACEA07-2EB0-4E77-91C0-0E26621468C2}" dt="2026-06-02T16:27:44.594" v="52" actId="207"/>
-      <pc:docMkLst>
-        <pc:docMk/>
-      </pc:docMkLst>
-      <pc:sldChg chg="modSp mod">
-        <pc:chgData name="Yofadikara Nurrohman" userId="92e6fe32f2f0c507" providerId="LiveId" clId="{F3ACEA07-2EB0-4E77-91C0-0E26621468C2}" dt="2026-06-02T16:27:44.594" v="52" actId="207"/>
-        <pc:sldMkLst>
-          <pc:docMk/>
-          <pc:sldMk cId="0" sldId="256"/>
-        </pc:sldMkLst>
-        <pc:spChg chg="mod">
-          <ac:chgData name="Yofadikara Nurrohman" userId="92e6fe32f2f0c507" providerId="LiveId" clId="{F3ACEA07-2EB0-4E77-91C0-0E26621468C2}" dt="2026-06-02T16:26:42.036" v="33" actId="207"/>
-          <ac:spMkLst>
-            <pc:docMk/>
-            <pc:sldMk cId="0" sldId="256"/>
-            <ac:spMk id="87" creationId="{00000000-0000-0000-0000-000000000000}"/>
-          </ac:spMkLst>
-        </pc:spChg>
-        <pc:spChg chg="mod">
-          <ac:chgData name="Yofadikara Nurrohman" userId="92e6fe32f2f0c507" providerId="LiveId" clId="{F3ACEA07-2EB0-4E77-91C0-0E26621468C2}" dt="2026-06-02T16:26:44.261" v="34" actId="207"/>
-          <ac:spMkLst>
-            <pc:docMk/>
-            <pc:sldMk cId="0" sldId="256"/>
-            <ac:spMk id="90" creationId="{00000000-0000-0000-0000-000000000000}"/>
-          </ac:spMkLst>
-        </pc:spChg>
-        <pc:spChg chg="mod">
-          <ac:chgData name="Yofadikara Nurrohman" userId="92e6fe32f2f0c507" providerId="LiveId" clId="{F3ACEA07-2EB0-4E77-91C0-0E26621468C2}" dt="2026-06-02T16:26:45.988" v="35" actId="207"/>
-          <ac:spMkLst>
-            <pc:docMk/>
-            <pc:sldMk cId="0" sldId="256"/>
-            <ac:spMk id="93" creationId="{00000000-0000-0000-0000-000000000000}"/>
-          </ac:spMkLst>
-        </pc:spChg>
-        <pc:spChg chg="mod">
-          <ac:chgData name="Yofadikara Nurrohman" userId="92e6fe32f2f0c507" providerId="LiveId" clId="{F3ACEA07-2EB0-4E77-91C0-0E26621468C2}" dt="2026-06-02T16:26:47.703" v="36" actId="207"/>
-          <ac:spMkLst>
-            <pc:docMk/>
-            <pc:sldMk cId="0" sldId="256"/>
-            <ac:spMk id="96" creationId="{00000000-0000-0000-0000-000000000000}"/>
-          </ac:spMkLst>
-        </pc:spChg>
-        <pc:spChg chg="mod">
-          <ac:chgData name="Yofadikara Nurrohman" userId="92e6fe32f2f0c507" providerId="LiveId" clId="{F3ACEA07-2EB0-4E77-91C0-0E26621468C2}" dt="2026-06-02T16:26:49.594" v="37" actId="207"/>
-          <ac:spMkLst>
-            <pc:docMk/>
-            <pc:sldMk cId="0" sldId="256"/>
-            <ac:spMk id="99" creationId="{00000000-0000-0000-0000-000000000000}"/>
-          </ac:spMkLst>
-        </pc:spChg>
-        <pc:spChg chg="mod">
-          <ac:chgData name="Yofadikara Nurrohman" userId="92e6fe32f2f0c507" providerId="LiveId" clId="{F3ACEA07-2EB0-4E77-91C0-0E26621468C2}" dt="2026-06-02T16:26:55.567" v="38" actId="207"/>
-          <ac:spMkLst>
-            <pc:docMk/>
-            <pc:sldMk cId="0" sldId="256"/>
-            <ac:spMk id="102" creationId="{00000000-0000-0000-0000-000000000000}"/>
-          </ac:spMkLst>
-        </pc:spChg>
-        <pc:spChg chg="mod">
-          <ac:chgData name="Yofadikara Nurrohman" userId="92e6fe32f2f0c507" providerId="LiveId" clId="{F3ACEA07-2EB0-4E77-91C0-0E26621468C2}" dt="2026-06-02T16:26:55.567" v="38" actId="207"/>
-          <ac:spMkLst>
-            <pc:docMk/>
-            <pc:sldMk cId="0" sldId="256"/>
-            <ac:spMk id="105" creationId="{00000000-0000-0000-0000-000000000000}"/>
-          </ac:spMkLst>
-        </pc:spChg>
-        <pc:spChg chg="mod">
-          <ac:chgData name="Yofadikara Nurrohman" userId="92e6fe32f2f0c507" providerId="LiveId" clId="{F3ACEA07-2EB0-4E77-91C0-0E26621468C2}" dt="2026-06-02T16:26:55.567" v="38" actId="207"/>
-          <ac:spMkLst>
-            <pc:docMk/>
-            <pc:sldMk cId="0" sldId="256"/>
-            <ac:spMk id="108" creationId="{00000000-0000-0000-0000-000000000000}"/>
-          </ac:spMkLst>
-        </pc:spChg>
-        <pc:spChg chg="mod">
-          <ac:chgData name="Yofadikara Nurrohman" userId="92e6fe32f2f0c507" providerId="LiveId" clId="{F3ACEA07-2EB0-4E77-91C0-0E26621468C2}" dt="2026-06-02T16:27:13.678" v="42" actId="207"/>
-          <ac:spMkLst>
-            <pc:docMk/>
-            <pc:sldMk cId="0" sldId="256"/>
-            <ac:spMk id="111" creationId="{00000000-0000-0000-0000-000000000000}"/>
-          </ac:spMkLst>
-        </pc:spChg>
-        <pc:spChg chg="mod">
-          <ac:chgData name="Yofadikara Nurrohman" userId="92e6fe32f2f0c507" providerId="LiveId" clId="{F3ACEA07-2EB0-4E77-91C0-0E26621468C2}" dt="2026-06-02T16:27:16.160" v="43" actId="207"/>
-          <ac:spMkLst>
-            <pc:docMk/>
-            <pc:sldMk cId="0" sldId="256"/>
-            <ac:spMk id="114" creationId="{00000000-0000-0000-0000-000000000000}"/>
-          </ac:spMkLst>
-        </pc:spChg>
-        <pc:spChg chg="mod">
-          <ac:chgData name="Yofadikara Nurrohman" userId="92e6fe32f2f0c507" providerId="LiveId" clId="{F3ACEA07-2EB0-4E77-91C0-0E26621468C2}" dt="2026-06-02T16:27:06.254" v="39" actId="207"/>
-          <ac:spMkLst>
-            <pc:docMk/>
-            <pc:sldMk cId="0" sldId="256"/>
-            <ac:spMk id="117" creationId="{00000000-0000-0000-0000-000000000000}"/>
-          </ac:spMkLst>
-        </pc:spChg>
-        <pc:spChg chg="mod">
-          <ac:chgData name="Yofadikara Nurrohman" userId="92e6fe32f2f0c507" providerId="LiveId" clId="{F3ACEA07-2EB0-4E77-91C0-0E26621468C2}" dt="2026-06-02T16:17:18.305" v="16" actId="207"/>
-          <ac:spMkLst>
-            <pc:docMk/>
-            <pc:sldMk cId="0" sldId="256"/>
-            <ac:spMk id="118" creationId="{00000000-0000-0000-0000-000000000000}"/>
-          </ac:spMkLst>
-        </pc:spChg>
-        <pc:spChg chg="mod">
-          <ac:chgData name="Yofadikara Nurrohman" userId="92e6fe32f2f0c507" providerId="LiveId" clId="{F3ACEA07-2EB0-4E77-91C0-0E26621468C2}" dt="2026-06-02T16:27:35.008" v="48" actId="207"/>
-          <ac:spMkLst>
-            <pc:docMk/>
-            <pc:sldMk cId="0" sldId="256"/>
-            <ac:spMk id="120" creationId="{00000000-0000-0000-0000-000000000000}"/>
-          </ac:spMkLst>
-        </pc:spChg>
-        <pc:spChg chg="mod">
-          <ac:chgData name="Yofadikara Nurrohman" userId="92e6fe32f2f0c507" providerId="LiveId" clId="{F3ACEA07-2EB0-4E77-91C0-0E26621468C2}" dt="2026-06-02T16:27:38.976" v="49" actId="207"/>
-          <ac:spMkLst>
-            <pc:docMk/>
-            <pc:sldMk cId="0" sldId="256"/>
-            <ac:spMk id="123" creationId="{00000000-0000-0000-0000-000000000000}"/>
-          </ac:spMkLst>
-        </pc:spChg>
-        <pc:spChg chg="mod">
-          <ac:chgData name="Yofadikara Nurrohman" userId="92e6fe32f2f0c507" providerId="LiveId" clId="{F3ACEA07-2EB0-4E77-91C0-0E26621468C2}" dt="2026-06-02T16:27:07.891" v="40" actId="207"/>
-          <ac:spMkLst>
-            <pc:docMk/>
-            <pc:sldMk cId="0" sldId="256"/>
-            <ac:spMk id="126" creationId="{00000000-0000-0000-0000-000000000000}"/>
-          </ac:spMkLst>
-        </pc:spChg>
-        <pc:spChg chg="mod">
-          <ac:chgData name="Yofadikara Nurrohman" userId="92e6fe32f2f0c507" providerId="LiveId" clId="{F3ACEA07-2EB0-4E77-91C0-0E26621468C2}" dt="2026-06-02T16:27:09.722" v="41" actId="207"/>
-          <ac:spMkLst>
-            <pc:docMk/>
-            <pc:sldMk cId="0" sldId="256"/>
-            <ac:spMk id="129" creationId="{00000000-0000-0000-0000-000000000000}"/>
-          </ac:spMkLst>
-        </pc:spChg>
-        <pc:spChg chg="mod">
-          <ac:chgData name="Yofadikara Nurrohman" userId="92e6fe32f2f0c507" providerId="LiveId" clId="{F3ACEA07-2EB0-4E77-91C0-0E26621468C2}" dt="2026-06-02T16:27:28.332" v="45" actId="207"/>
-          <ac:spMkLst>
-            <pc:docMk/>
-            <pc:sldMk cId="0" sldId="256"/>
-            <ac:spMk id="132" creationId="{00000000-0000-0000-0000-000000000000}"/>
-          </ac:spMkLst>
-        </pc:spChg>
-        <pc:spChg chg="mod">
-          <ac:chgData name="Yofadikara Nurrohman" userId="92e6fe32f2f0c507" providerId="LiveId" clId="{F3ACEA07-2EB0-4E77-91C0-0E26621468C2}" dt="2026-06-02T16:17:43.825" v="24" actId="207"/>
-          <ac:spMkLst>
-            <pc:docMk/>
-            <pc:sldMk cId="0" sldId="256"/>
-            <ac:spMk id="133" creationId="{00000000-0000-0000-0000-000000000000}"/>
-          </ac:spMkLst>
-        </pc:spChg>
-        <pc:spChg chg="mod">
-          <ac:chgData name="Yofadikara Nurrohman" userId="92e6fe32f2f0c507" providerId="LiveId" clId="{F3ACEA07-2EB0-4E77-91C0-0E26621468C2}" dt="2026-06-02T16:27:30.704" v="46" actId="207"/>
-          <ac:spMkLst>
-            <pc:docMk/>
-            <pc:sldMk cId="0" sldId="256"/>
-            <ac:spMk id="135" creationId="{00000000-0000-0000-0000-000000000000}"/>
-          </ac:spMkLst>
-        </pc:spChg>
-        <pc:spChg chg="mod">
-          <ac:chgData name="Yofadikara Nurrohman" userId="92e6fe32f2f0c507" providerId="LiveId" clId="{F3ACEA07-2EB0-4E77-91C0-0E26621468C2}" dt="2026-06-02T16:27:32.790" v="47" actId="207"/>
-          <ac:spMkLst>
-            <pc:docMk/>
-            <pc:sldMk cId="0" sldId="256"/>
-            <ac:spMk id="138" creationId="{00000000-0000-0000-0000-000000000000}"/>
-          </ac:spMkLst>
-        </pc:spChg>
-        <pc:spChg chg="mod">
-          <ac:chgData name="Yofadikara Nurrohman" userId="92e6fe32f2f0c507" providerId="LiveId" clId="{F3ACEA07-2EB0-4E77-91C0-0E26621468C2}" dt="2026-06-02T16:27:40.948" v="50" actId="207"/>
-          <ac:spMkLst>
-            <pc:docMk/>
-            <pc:sldMk cId="0" sldId="256"/>
-            <ac:spMk id="145" creationId="{00000000-0000-0000-0000-000000000000}"/>
-          </ac:spMkLst>
-        </pc:spChg>
-        <pc:spChg chg="mod">
-          <ac:chgData name="Yofadikara Nurrohman" userId="92e6fe32f2f0c507" providerId="LiveId" clId="{F3ACEA07-2EB0-4E77-91C0-0E26621468C2}" dt="2026-06-02T16:27:42.734" v="51" actId="207"/>
-          <ac:spMkLst>
-            <pc:docMk/>
-            <pc:sldMk cId="0" sldId="256"/>
-            <ac:spMk id="149" creationId="{00000000-0000-0000-0000-000000000000}"/>
-          </ac:spMkLst>
-        </pc:spChg>
-        <pc:spChg chg="mod">
-          <ac:chgData name="Yofadikara Nurrohman" userId="92e6fe32f2f0c507" providerId="LiveId" clId="{F3ACEA07-2EB0-4E77-91C0-0E26621468C2}" dt="2026-06-02T16:27:44.594" v="52" actId="207"/>
-          <ac:spMkLst>
-            <pc:docMk/>
-            <pc:sldMk cId="0" sldId="256"/>
-            <ac:spMk id="152" creationId="{00000000-0000-0000-0000-000000000000}"/>
-          </ac:spMkLst>
-        </pc:spChg>
-        <pc:spChg chg="mod">
-          <ac:chgData name="Yofadikara Nurrohman" userId="92e6fe32f2f0c507" providerId="LiveId" clId="{F3ACEA07-2EB0-4E77-91C0-0E26621468C2}" dt="2026-06-02T16:27:18.297" v="44" actId="207"/>
-          <ac:spMkLst>
-            <pc:docMk/>
-            <pc:sldMk cId="0" sldId="256"/>
-            <ac:spMk id="155" creationId="{00000000-0000-0000-0000-000000000000}"/>
-          </ac:spMkLst>
-        </pc:spChg>
-        <pc:grpChg chg="mod">
-          <ac:chgData name="Yofadikara Nurrohman" userId="92e6fe32f2f0c507" providerId="LiveId" clId="{F3ACEA07-2EB0-4E77-91C0-0E26621468C2}" dt="2026-06-02T16:17:18.305" v="16" actId="207"/>
-          <ac:grpSpMkLst>
-            <pc:docMk/>
-            <pc:sldMk cId="0" sldId="256"/>
-            <ac:grpSpMk id="116" creationId="{00000000-0000-0000-0000-000000000000}"/>
-          </ac:grpSpMkLst>
-        </pc:grpChg>
-        <pc:grpChg chg="mod">
-          <ac:chgData name="Yofadikara Nurrohman" userId="92e6fe32f2f0c507" providerId="LiveId" clId="{F3ACEA07-2EB0-4E77-91C0-0E26621468C2}" dt="2026-06-02T16:17:43.825" v="24" actId="207"/>
-          <ac:grpSpMkLst>
-            <pc:docMk/>
-            <pc:sldMk cId="0" sldId="256"/>
-            <ac:grpSpMk id="131" creationId="{00000000-0000-0000-0000-000000000000}"/>
-          </ac:grpSpMkLst>
-        </pc:grpChg>
       </pc:sldChg>
     </pc:docChg>
   </pc:docChgLst>
@@ -1411,7 +264,7 @@
           <a:p>
             <a:fld id="{3EA2A906-D963-4E59-B973-88DF90B95021}" type="datetimeFigureOut">
               <a:rPr lang="en-US" smtClean="0"/>
-              <a:t>6/2/2026</a:t>
+              <a:t>9/17/2026</a:t>
             </a:fld>
             <a:endParaRPr lang="en-US"/>
           </a:p>
@@ -1942,7 +795,7 @@
             <a:fld id="{1D8BD707-D9CF-40AE-B4C6-C98DA3205C09}" type="datetimeFigureOut">
               <a:rPr lang="en-US" smtClean="0"/>
               <a:pPr/>
-              <a:t>6/2/2026</a:t>
+              <a:t>9/17/2026</a:t>
             </a:fld>
             <a:endParaRPr lang="en-US"/>
           </a:p>
@@ -2107,7 +960,7 @@
             <a:fld id="{1D8BD707-D9CF-40AE-B4C6-C98DA3205C09}" type="datetimeFigureOut">
               <a:rPr lang="en-US" smtClean="0"/>
               <a:pPr/>
-              <a:t>6/2/2026</a:t>
+              <a:t>9/17/2026</a:t>
             </a:fld>
             <a:endParaRPr lang="en-US"/>
           </a:p>
@@ -2282,7 +1135,7 @@
             <a:fld id="{1D8BD707-D9CF-40AE-B4C6-C98DA3205C09}" type="datetimeFigureOut">
               <a:rPr lang="en-US" smtClean="0"/>
               <a:pPr/>
-              <a:t>6/2/2026</a:t>
+              <a:t>9/17/2026</a:t>
             </a:fld>
             <a:endParaRPr lang="en-US"/>
           </a:p>
@@ -2447,7 +1300,7 @@
             <a:fld id="{1D8BD707-D9CF-40AE-B4C6-C98DA3205C09}" type="datetimeFigureOut">
               <a:rPr lang="en-US" smtClean="0"/>
               <a:pPr/>
-              <a:t>6/2/2026</a:t>
+              <a:t>9/17/2026</a:t>
             </a:fld>
             <a:endParaRPr lang="en-US"/>
           </a:p>
@@ -2689,7 +1542,7 @@
             <a:fld id="{1D8BD707-D9CF-40AE-B4C6-C98DA3205C09}" type="datetimeFigureOut">
               <a:rPr lang="en-US" smtClean="0"/>
               <a:pPr/>
-              <a:t>6/2/2026</a:t>
+              <a:t>9/17/2026</a:t>
             </a:fld>
             <a:endParaRPr lang="en-US"/>
           </a:p>
@@ -2971,7 +1824,7 @@
             <a:fld id="{1D8BD707-D9CF-40AE-B4C6-C98DA3205C09}" type="datetimeFigureOut">
               <a:rPr lang="en-US" smtClean="0"/>
               <a:pPr/>
-              <a:t>6/2/2026</a:t>
+              <a:t>9/17/2026</a:t>
             </a:fld>
             <a:endParaRPr lang="en-US"/>
           </a:p>
@@ -3387,7 +2240,7 @@
             <a:fld id="{1D8BD707-D9CF-40AE-B4C6-C98DA3205C09}" type="datetimeFigureOut">
               <a:rPr lang="en-US" smtClean="0"/>
               <a:pPr/>
-              <a:t>6/2/2026</a:t>
+              <a:t>9/17/2026</a:t>
             </a:fld>
             <a:endParaRPr lang="en-US"/>
           </a:p>
@@ -3501,7 +2354,7 @@
             <a:fld id="{1D8BD707-D9CF-40AE-B4C6-C98DA3205C09}" type="datetimeFigureOut">
               <a:rPr lang="en-US" smtClean="0"/>
               <a:pPr/>
-              <a:t>6/2/2026</a:t>
+              <a:t>9/17/2026</a:t>
             </a:fld>
             <a:endParaRPr lang="en-US"/>
           </a:p>
@@ -3593,7 +2446,7 @@
             <a:fld id="{1D8BD707-D9CF-40AE-B4C6-C98DA3205C09}" type="datetimeFigureOut">
               <a:rPr lang="en-US" smtClean="0"/>
               <a:pPr/>
-              <a:t>6/2/2026</a:t>
+              <a:t>9/17/2026</a:t>
             </a:fld>
             <a:endParaRPr lang="en-US"/>
           </a:p>
@@ -3865,7 +2718,7 @@
             <a:fld id="{1D8BD707-D9CF-40AE-B4C6-C98DA3205C09}" type="datetimeFigureOut">
               <a:rPr lang="en-US" smtClean="0"/>
               <a:pPr/>
-              <a:t>6/2/2026</a:t>
+              <a:t>9/17/2026</a:t>
             </a:fld>
             <a:endParaRPr lang="en-US"/>
           </a:p>
@@ -4114,7 +2967,7 @@
             <a:fld id="{1D8BD707-D9CF-40AE-B4C6-C98DA3205C09}" type="datetimeFigureOut">
               <a:rPr lang="en-US" smtClean="0"/>
               <a:pPr/>
-              <a:t>6/2/2026</a:t>
+              <a:t>9/17/2026</a:t>
             </a:fld>
             <a:endParaRPr lang="en-US"/>
           </a:p>
@@ -4322,7 +3175,7 @@
             <a:fld id="{1D8BD707-D9CF-40AE-B4C6-C98DA3205C09}" type="datetimeFigureOut">
               <a:rPr lang="en-US" smtClean="0"/>
               <a:pPr/>
-              <a:t>6/2/2026</a:t>
+              <a:t>9/17/2026</a:t>
             </a:fld>
             <a:endParaRPr lang="en-US"/>
           </a:p>
@@ -14820,7 +13673,7 @@
         <p:spPr>
           <a:xfrm>
             <a:off x="9220201" y="3200006"/>
-            <a:ext cx="3082308" cy="243656"/>
+            <a:ext cx="3082308" cy="229102"/>
           </a:xfrm>
           <a:prstGeom prst="rect">
             <a:avLst/>
@@ -14838,7 +13691,7 @@
               </a:lnSpc>
             </a:pPr>
             <a:r>
-              <a:rPr lang="en-US" sz="1600" dirty="0" err="1">
+              <a:rPr lang="en-US" sz="1400" dirty="0" err="1">
                 <a:solidFill>
                   <a:srgbClr val="FFFFFF"/>
                 </a:solidFill>
@@ -14850,7 +13703,7 @@
               <a:t>Jumlah</a:t>
             </a:r>
             <a:r>
-              <a:rPr lang="en-US" sz="1600" dirty="0">
+              <a:rPr lang="en-US" sz="1400" dirty="0">
                 <a:solidFill>
                   <a:srgbClr val="FFFFFF"/>
                 </a:solidFill>
@@ -14862,7 +13715,7 @@
               <a:t> ASN Per {</a:t>
             </a:r>
             <a:r>
-              <a:rPr lang="en-US" sz="1600" dirty="0" err="1">
+              <a:rPr lang="en-US" sz="1400" dirty="0" err="1">
                 <a:solidFill>
                   <a:srgbClr val="FFFFFF"/>
                 </a:solidFill>
@@ -14874,7 +13727,7 @@
               <a:t>tanggal_data</a:t>
             </a:r>
             <a:r>
-              <a:rPr lang="en-US" sz="1600" dirty="0">
+              <a:rPr lang="en-US" sz="1400" dirty="0">
                 <a:solidFill>
                   <a:srgbClr val="FFFFFF"/>
                 </a:solidFill>
@@ -18851,15 +17704,15 @@
         </p:nvSpPr>
         <p:spPr>
           <a:xfrm>
-            <a:off x="6721541" y="1141232"/>
-            <a:ext cx="4844918" cy="457200"/>
+            <a:off x="6400800" y="1141232"/>
+            <a:ext cx="5562599" cy="457200"/>
           </a:xfrm>
           <a:prstGeom prst="rect">
             <a:avLst/>
           </a:prstGeom>
         </p:spPr>
         <p:txBody>
-          <a:bodyPr lIns="0" tIns="0" rIns="0" bIns="0" rtlCol="0" anchor="t">
+          <a:bodyPr wrap="square" lIns="0" tIns="0" rIns="0" bIns="0" rtlCol="0" anchor="t">
             <a:spAutoFit/>
           </a:bodyPr>
           <a:lstStyle/>

</xml_diff>